<commit_message>
Added description of building of repositories
</commit_message>
<xml_diff>
--- a/assets/images/Repositories.pptx
+++ b/assets/images/Repositories.pptx
@@ -5,14 +5,10 @@
     <p:sldMasterId id="2147483684" r:id="rId4"/>
   </p:sldMasterIdLst>
   <p:notesMasterIdLst>
-    <p:notesMasterId r:id="rId10"/>
+    <p:notesMasterId r:id="rId6"/>
   </p:notesMasterIdLst>
   <p:sldIdLst>
     <p:sldId id="256" r:id="rId5"/>
-    <p:sldId id="257" r:id="rId6"/>
-    <p:sldId id="259" r:id="rId7"/>
-    <p:sldId id="260" r:id="rId8"/>
-    <p:sldId id="261" r:id="rId9"/>
   </p:sldIdLst>
   <p:sldSz cx="21601113" cy="14400213"/>
   <p:notesSz cx="9144000" cy="6858000"/>
@@ -406,7 +402,7 @@
           <a:p>
             <a:fld id="{43466010-90F5-41E6-AAE8-7E580DBF8C7C}" type="datetimeFigureOut">
               <a:rPr lang="en-DK" smtClean="0"/>
-              <a:t>23/02/2026</a:t>
+              <a:t>04/05/2026</a:t>
             </a:fld>
             <a:endParaRPr lang="en-DK"/>
           </a:p>
@@ -762,94 +758,6 @@
 </p:notes>
 </file>
 
-<file path=ppt/notesSlides/notesSlide2.xml><?xml version="1.0" encoding="utf-8"?>
-<p:notes xmlns:a="http://schemas.openxmlformats.org/drawingml/2006/main" xmlns:r="http://schemas.openxmlformats.org/officeDocument/2006/relationships" xmlns:p="http://schemas.openxmlformats.org/presentationml/2006/main">
-  <p:cSld>
-    <p:spTree>
-      <p:nvGrpSpPr>
-        <p:cNvPr id="1" name=""/>
-        <p:cNvGrpSpPr/>
-        <p:nvPr/>
-      </p:nvGrpSpPr>
-      <p:grpSpPr>
-        <a:xfrm>
-          <a:off x="0" y="0"/>
-          <a:ext cx="0" cy="0"/>
-          <a:chOff x="0" y="0"/>
-          <a:chExt cx="0" cy="0"/>
-        </a:xfrm>
-      </p:grpSpPr>
-      <p:sp>
-        <p:nvSpPr>
-          <p:cNvPr id="2" name="Slide Image Placeholder 1"/>
-          <p:cNvSpPr>
-            <a:spLocks noGrp="1" noRot="1" noChangeAspect="1"/>
-          </p:cNvSpPr>
-          <p:nvPr>
-            <p:ph type="sldImg"/>
-          </p:nvPr>
-        </p:nvSpPr>
-        <p:spPr/>
-      </p:sp>
-      <p:sp>
-        <p:nvSpPr>
-          <p:cNvPr id="3" name="Notes Placeholder 2"/>
-          <p:cNvSpPr>
-            <a:spLocks noGrp="1"/>
-          </p:cNvSpPr>
-          <p:nvPr>
-            <p:ph type="body" idx="1"/>
-          </p:nvPr>
-        </p:nvSpPr>
-        <p:spPr/>
-        <p:txBody>
-          <a:bodyPr/>
-          <a:lstStyle/>
-          <a:p>
-            <a:r>
-              <a:rPr lang="en-GB" dirty="0"/>
-              <a:t>LabBench I/O</a:t>
-            </a:r>
-            <a:endParaRPr lang="en-DK" dirty="0"/>
-          </a:p>
-        </p:txBody>
-      </p:sp>
-      <p:sp>
-        <p:nvSpPr>
-          <p:cNvPr id="4" name="Slide Number Placeholder 3"/>
-          <p:cNvSpPr>
-            <a:spLocks noGrp="1"/>
-          </p:cNvSpPr>
-          <p:nvPr>
-            <p:ph type="sldNum" sz="quarter" idx="5"/>
-          </p:nvPr>
-        </p:nvSpPr>
-        <p:spPr/>
-        <p:txBody>
-          <a:bodyPr/>
-          <a:lstStyle/>
-          <a:p>
-            <a:fld id="{A20644BD-399A-490A-99CC-829CA96D1157}" type="slidenum">
-              <a:rPr lang="en-DK" smtClean="0"/>
-              <a:t>2</a:t>
-            </a:fld>
-            <a:endParaRPr lang="en-DK"/>
-          </a:p>
-        </p:txBody>
-      </p:sp>
-    </p:spTree>
-    <p:extLst>
-      <p:ext uri="{BB962C8B-B14F-4D97-AF65-F5344CB8AC3E}">
-        <p14:creationId xmlns:p14="http://schemas.microsoft.com/office/powerpoint/2010/main" val="99399054"/>
-      </p:ext>
-    </p:extLst>
-  </p:cSld>
-  <p:clrMapOvr>
-    <a:masterClrMapping/>
-  </p:clrMapOvr>
-</p:notes>
-</file>
-
 <file path=ppt/slideLayouts/slideLayout1.xml><?xml version="1.0" encoding="utf-8"?>
 <p:sldLayout xmlns:a="http://schemas.openxmlformats.org/drawingml/2006/main" xmlns:r="http://schemas.openxmlformats.org/officeDocument/2006/relationships" xmlns:p="http://schemas.openxmlformats.org/presentationml/2006/main" type="title" preserve="1">
   <p:cSld name="Title Slide">
@@ -981,7 +889,7 @@
           <a:p>
             <a:fld id="{F1465E3F-0B9F-47C9-9E08-5C827E095B3E}" type="datetimeFigureOut">
               <a:rPr lang="en-DK" smtClean="0"/>
-              <a:t>23/02/2026</a:t>
+              <a:t>04/05/2026</a:t>
             </a:fld>
             <a:endParaRPr lang="en-DK"/>
           </a:p>
@@ -1151,7 +1059,7 @@
           <a:p>
             <a:fld id="{F1465E3F-0B9F-47C9-9E08-5C827E095B3E}" type="datetimeFigureOut">
               <a:rPr lang="en-DK" smtClean="0"/>
-              <a:t>23/02/2026</a:t>
+              <a:t>04/05/2026</a:t>
             </a:fld>
             <a:endParaRPr lang="en-DK"/>
           </a:p>
@@ -1331,7 +1239,7 @@
           <a:p>
             <a:fld id="{F1465E3F-0B9F-47C9-9E08-5C827E095B3E}" type="datetimeFigureOut">
               <a:rPr lang="en-DK" smtClean="0"/>
-              <a:t>23/02/2026</a:t>
+              <a:t>04/05/2026</a:t>
             </a:fld>
             <a:endParaRPr lang="en-DK"/>
           </a:p>
@@ -1501,7 +1409,7 @@
           <a:p>
             <a:fld id="{F1465E3F-0B9F-47C9-9E08-5C827E095B3E}" type="datetimeFigureOut">
               <a:rPr lang="en-DK" smtClean="0"/>
-              <a:t>23/02/2026</a:t>
+              <a:t>04/05/2026</a:t>
             </a:fld>
             <a:endParaRPr lang="en-DK"/>
           </a:p>
@@ -1747,7 +1655,7 @@
           <a:p>
             <a:fld id="{F1465E3F-0B9F-47C9-9E08-5C827E095B3E}" type="datetimeFigureOut">
               <a:rPr lang="en-DK" smtClean="0"/>
-              <a:t>23/02/2026</a:t>
+              <a:t>04/05/2026</a:t>
             </a:fld>
             <a:endParaRPr lang="en-DK"/>
           </a:p>
@@ -1979,7 +1887,7 @@
           <a:p>
             <a:fld id="{F1465E3F-0B9F-47C9-9E08-5C827E095B3E}" type="datetimeFigureOut">
               <a:rPr lang="en-DK" smtClean="0"/>
-              <a:t>23/02/2026</a:t>
+              <a:t>04/05/2026</a:t>
             </a:fld>
             <a:endParaRPr lang="en-DK"/>
           </a:p>
@@ -2346,7 +2254,7 @@
           <a:p>
             <a:fld id="{F1465E3F-0B9F-47C9-9E08-5C827E095B3E}" type="datetimeFigureOut">
               <a:rPr lang="en-DK" smtClean="0"/>
-              <a:t>23/02/2026</a:t>
+              <a:t>04/05/2026</a:t>
             </a:fld>
             <a:endParaRPr lang="en-DK"/>
           </a:p>
@@ -2464,7 +2372,7 @@
           <a:p>
             <a:fld id="{F1465E3F-0B9F-47C9-9E08-5C827E095B3E}" type="datetimeFigureOut">
               <a:rPr lang="en-DK" smtClean="0"/>
-              <a:t>23/02/2026</a:t>
+              <a:t>04/05/2026</a:t>
             </a:fld>
             <a:endParaRPr lang="en-DK"/>
           </a:p>
@@ -2559,7 +2467,7 @@
           <a:p>
             <a:fld id="{F1465E3F-0B9F-47C9-9E08-5C827E095B3E}" type="datetimeFigureOut">
               <a:rPr lang="en-DK" smtClean="0"/>
-              <a:t>23/02/2026</a:t>
+              <a:t>04/05/2026</a:t>
             </a:fld>
             <a:endParaRPr lang="en-DK"/>
           </a:p>
@@ -2836,7 +2744,7 @@
           <a:p>
             <a:fld id="{F1465E3F-0B9F-47C9-9E08-5C827E095B3E}" type="datetimeFigureOut">
               <a:rPr lang="en-DK" smtClean="0"/>
-              <a:t>23/02/2026</a:t>
+              <a:t>04/05/2026</a:t>
             </a:fld>
             <a:endParaRPr lang="en-DK"/>
           </a:p>
@@ -3093,7 +3001,7 @@
           <a:p>
             <a:fld id="{F1465E3F-0B9F-47C9-9E08-5C827E095B3E}" type="datetimeFigureOut">
               <a:rPr lang="en-DK" smtClean="0"/>
-              <a:t>23/02/2026</a:t>
+              <a:t>04/05/2026</a:t>
             </a:fld>
             <a:endParaRPr lang="en-DK"/>
           </a:p>
@@ -3306,7 +3214,7 @@
           <a:p>
             <a:fld id="{F1465E3F-0B9F-47C9-9E08-5C827E095B3E}" type="datetimeFigureOut">
               <a:rPr lang="en-DK" smtClean="0"/>
-              <a:t>23/02/2026</a:t>
+              <a:t>04/05/2026</a:t>
             </a:fld>
             <a:endParaRPr lang="en-DK"/>
           </a:p>
@@ -3713,10 +3621,10 @@
       </p:grpSpPr>
       <p:pic>
         <p:nvPicPr>
-          <p:cNvPr id="3" name="Picture 2" descr="The image displays a Windows installation screen for LabBench 6, with a prompt to install a 64 MB software package and agree to license terms.&#10;&#10;AI-generated content may be incorrect.">
+          <p:cNvPr id="4" name="Picture 3" descr="The image displays a software interface for LabBench Protocol Repository, showcasing a list of various scientific protocols and projects, including those related to Neuroscience and Precision Health.&#10;&#10;AI-generated content may be incorrect.">
             <a:extLst>
               <a:ext uri="{FF2B5EF4-FFF2-40B4-BE49-F238E27FC236}">
-                <a16:creationId xmlns:a16="http://schemas.microsoft.com/office/drawing/2014/main" id="{5AB23F53-45FF-E104-B941-3C6AF9FAC86F}"/>
+                <a16:creationId xmlns:a16="http://schemas.microsoft.com/office/drawing/2014/main" id="{01C1370F-2884-9D7F-BB8E-70A8305247A4}"/>
               </a:ext>
             </a:extLst>
           </p:cNvPr>
@@ -3733,610 +3641,20 @@
         </p:blipFill>
         <p:spPr>
           <a:xfrm>
-            <a:off x="4796377" y="4544018"/>
-            <a:ext cx="1800000" cy="2232468"/>
+            <a:off x="4890294" y="4375944"/>
+            <a:ext cx="11820525" cy="5648325"/>
           </a:xfrm>
           <a:prstGeom prst="rect">
             <a:avLst/>
           </a:prstGeom>
         </p:spPr>
       </p:pic>
-      <p:pic>
-        <p:nvPicPr>
-          <p:cNvPr id="5" name="Picture 4" descr="The image shows a software installation page for LabBench 6, specifically for selecting prerequisites to install .NET Desktop Runtime versions 10.0.2 or 10.0.3.&#10;&#10;AI-generated content may be incorrect.">
+      <p:sp>
+        <p:nvSpPr>
+          <p:cNvPr id="6" name="Oval 5">
             <a:extLst>
               <a:ext uri="{FF2B5EF4-FFF2-40B4-BE49-F238E27FC236}">
-                <a16:creationId xmlns:a16="http://schemas.microsoft.com/office/drawing/2014/main" id="{F2445D1F-346E-FED9-9F2C-B510DCBE1CD3}"/>
-              </a:ext>
-            </a:extLst>
-          </p:cNvPr>
-          <p:cNvPicPr>
-            <a:picLocks noChangeAspect="1"/>
-          </p:cNvPicPr>
-          <p:nvPr/>
-        </p:nvPicPr>
-        <p:blipFill>
-          <a:blip r:embed="rId4"/>
-          <a:stretch>
-            <a:fillRect/>
-          </a:stretch>
-        </p:blipFill>
-        <p:spPr>
-          <a:xfrm>
-            <a:off x="6899223" y="4544018"/>
-            <a:ext cx="1800000" cy="2232468"/>
-          </a:xfrm>
-          <a:prstGeom prst="rect">
-            <a:avLst/>
-          </a:prstGeom>
-        </p:spPr>
-      </p:pic>
-      <p:pic>
-        <p:nvPicPr>
-          <p:cNvPr id="7" name="Picture 6" descr="The image is a software installation screen for LabBench 6, offering two installation options: for the individual user or for all users.&#10;&#10;AI-generated content may be incorrect.">
-            <a:extLst>
-              <a:ext uri="{FF2B5EF4-FFF2-40B4-BE49-F238E27FC236}">
-                <a16:creationId xmlns:a16="http://schemas.microsoft.com/office/drawing/2014/main" id="{51F0A6CD-E60D-550A-9D9A-24E5CD86A719}"/>
-              </a:ext>
-            </a:extLst>
-          </p:cNvPr>
-          <p:cNvPicPr>
-            <a:picLocks noChangeAspect="1"/>
-          </p:cNvPicPr>
-          <p:nvPr/>
-        </p:nvPicPr>
-        <p:blipFill>
-          <a:blip r:embed="rId5"/>
-          <a:stretch>
-            <a:fillRect/>
-          </a:stretch>
-        </p:blipFill>
-        <p:spPr>
-          <a:xfrm>
-            <a:off x="9002069" y="4544018"/>
-            <a:ext cx="1800000" cy="2232468"/>
-          </a:xfrm>
-          <a:prstGeom prst="rect">
-            <a:avLst/>
-          </a:prstGeom>
-        </p:spPr>
-      </p:pic>
-      <p:pic>
-        <p:nvPicPr>
-          <p:cNvPr id="9" name="Picture 8" descr="Copying new files&#10;&#10;AI-generated content may be incorrect.">
-            <a:extLst>
-              <a:ext uri="{FF2B5EF4-FFF2-40B4-BE49-F238E27FC236}">
-                <a16:creationId xmlns:a16="http://schemas.microsoft.com/office/drawing/2014/main" id="{269A1BF7-755A-57E3-E6C2-A704B96CA6B3}"/>
-              </a:ext>
-            </a:extLst>
-          </p:cNvPr>
-          <p:cNvPicPr>
-            <a:picLocks noChangeAspect="1"/>
-          </p:cNvPicPr>
-          <p:nvPr/>
-        </p:nvPicPr>
-        <p:blipFill>
-          <a:blip r:embed="rId6"/>
-          <a:stretch>
-            <a:fillRect/>
-          </a:stretch>
-        </p:blipFill>
-        <p:spPr>
-          <a:xfrm>
-            <a:off x="11104915" y="4544018"/>
-            <a:ext cx="1800000" cy="2232468"/>
-          </a:xfrm>
-          <a:prstGeom prst="rect">
-            <a:avLst/>
-          </a:prstGeom>
-        </p:spPr>
-      </p:pic>
-      <p:pic>
-        <p:nvPicPr>
-          <p:cNvPr id="11" name="Picture 10" descr="LabBench 6 installation is complete on Inventors Way.&#10;&#10;AI-generated content may be incorrect.">
-            <a:extLst>
-              <a:ext uri="{FF2B5EF4-FFF2-40B4-BE49-F238E27FC236}">
-                <a16:creationId xmlns:a16="http://schemas.microsoft.com/office/drawing/2014/main" id="{1A89F56A-2793-5622-0B4E-A6316A8AC347}"/>
-              </a:ext>
-            </a:extLst>
-          </p:cNvPr>
-          <p:cNvPicPr>
-            <a:picLocks noChangeAspect="1"/>
-          </p:cNvPicPr>
-          <p:nvPr/>
-        </p:nvPicPr>
-        <p:blipFill>
-          <a:blip r:embed="rId7"/>
-          <a:stretch>
-            <a:fillRect/>
-          </a:stretch>
-        </p:blipFill>
-        <p:spPr>
-          <a:xfrm>
-            <a:off x="13207761" y="4544018"/>
-            <a:ext cx="1800000" cy="2232468"/>
-          </a:xfrm>
-          <a:prstGeom prst="rect">
-            <a:avLst/>
-          </a:prstGeom>
-        </p:spPr>
-      </p:pic>
-      <p:cxnSp>
-        <p:nvCxnSpPr>
-          <p:cNvPr id="20" name="Straight Arrow Connector 19">
-            <a:extLst>
-              <a:ext uri="{FF2B5EF4-FFF2-40B4-BE49-F238E27FC236}">
-                <a16:creationId xmlns:a16="http://schemas.microsoft.com/office/drawing/2014/main" id="{BC313507-CAB6-101A-82E0-D9A1741B4E9F}"/>
-              </a:ext>
-            </a:extLst>
-          </p:cNvPr>
-          <p:cNvCxnSpPr>
-            <a:cxnSpLocks/>
-          </p:cNvCxnSpPr>
-          <p:nvPr/>
-        </p:nvCxnSpPr>
-        <p:spPr>
-          <a:xfrm>
-            <a:off x="6596377" y="5660252"/>
-            <a:ext cx="302846" cy="0"/>
-          </a:xfrm>
-          <a:prstGeom prst="straightConnector1">
-            <a:avLst/>
-          </a:prstGeom>
-          <a:ln w="38100">
-            <a:tailEnd type="triangle"/>
-          </a:ln>
-        </p:spPr>
-        <p:style>
-          <a:lnRef idx="2">
-            <a:schemeClr val="dk1"/>
-          </a:lnRef>
-          <a:fillRef idx="0">
-            <a:schemeClr val="dk1"/>
-          </a:fillRef>
-          <a:effectRef idx="1">
-            <a:schemeClr val="dk1"/>
-          </a:effectRef>
-          <a:fontRef idx="minor">
-            <a:schemeClr val="tx1"/>
-          </a:fontRef>
-        </p:style>
-      </p:cxnSp>
-      <p:cxnSp>
-        <p:nvCxnSpPr>
-          <p:cNvPr id="24" name="Straight Arrow Connector 23">
-            <a:extLst>
-              <a:ext uri="{FF2B5EF4-FFF2-40B4-BE49-F238E27FC236}">
-                <a16:creationId xmlns:a16="http://schemas.microsoft.com/office/drawing/2014/main" id="{81E6B4DC-1C34-D74A-3073-0693DCD82C59}"/>
-              </a:ext>
-            </a:extLst>
-          </p:cNvPr>
-          <p:cNvCxnSpPr>
-            <a:cxnSpLocks/>
-          </p:cNvCxnSpPr>
-          <p:nvPr/>
-        </p:nvCxnSpPr>
-        <p:spPr>
-          <a:xfrm>
-            <a:off x="8699223" y="5660252"/>
-            <a:ext cx="302846" cy="0"/>
-          </a:xfrm>
-          <a:prstGeom prst="straightConnector1">
-            <a:avLst/>
-          </a:prstGeom>
-          <a:ln w="38100">
-            <a:tailEnd type="triangle"/>
-          </a:ln>
-        </p:spPr>
-        <p:style>
-          <a:lnRef idx="2">
-            <a:schemeClr val="dk1"/>
-          </a:lnRef>
-          <a:fillRef idx="0">
-            <a:schemeClr val="dk1"/>
-          </a:fillRef>
-          <a:effectRef idx="1">
-            <a:schemeClr val="dk1"/>
-          </a:effectRef>
-          <a:fontRef idx="minor">
-            <a:schemeClr val="tx1"/>
-          </a:fontRef>
-        </p:style>
-      </p:cxnSp>
-      <p:cxnSp>
-        <p:nvCxnSpPr>
-          <p:cNvPr id="25" name="Straight Arrow Connector 24">
-            <a:extLst>
-              <a:ext uri="{FF2B5EF4-FFF2-40B4-BE49-F238E27FC236}">
-                <a16:creationId xmlns:a16="http://schemas.microsoft.com/office/drawing/2014/main" id="{18A6C2AA-0F7B-8EFD-F402-132D239DBE8E}"/>
-              </a:ext>
-            </a:extLst>
-          </p:cNvPr>
-          <p:cNvCxnSpPr>
-            <a:cxnSpLocks/>
-          </p:cNvCxnSpPr>
-          <p:nvPr/>
-        </p:nvCxnSpPr>
-        <p:spPr>
-          <a:xfrm>
-            <a:off x="10802069" y="5660252"/>
-            <a:ext cx="302846" cy="0"/>
-          </a:xfrm>
-          <a:prstGeom prst="straightConnector1">
-            <a:avLst/>
-          </a:prstGeom>
-          <a:ln w="38100">
-            <a:tailEnd type="triangle"/>
-          </a:ln>
-        </p:spPr>
-        <p:style>
-          <a:lnRef idx="2">
-            <a:schemeClr val="dk1"/>
-          </a:lnRef>
-          <a:fillRef idx="0">
-            <a:schemeClr val="dk1"/>
-          </a:fillRef>
-          <a:effectRef idx="1">
-            <a:schemeClr val="dk1"/>
-          </a:effectRef>
-          <a:fontRef idx="minor">
-            <a:schemeClr val="tx1"/>
-          </a:fontRef>
-        </p:style>
-      </p:cxnSp>
-      <p:cxnSp>
-        <p:nvCxnSpPr>
-          <p:cNvPr id="26" name="Straight Arrow Connector 25">
-            <a:extLst>
-              <a:ext uri="{FF2B5EF4-FFF2-40B4-BE49-F238E27FC236}">
-                <a16:creationId xmlns:a16="http://schemas.microsoft.com/office/drawing/2014/main" id="{680FCD68-7D04-8F8B-3320-C54CA1BA1603}"/>
-              </a:ext>
-            </a:extLst>
-          </p:cNvPr>
-          <p:cNvCxnSpPr>
-            <a:cxnSpLocks/>
-          </p:cNvCxnSpPr>
-          <p:nvPr/>
-        </p:nvCxnSpPr>
-        <p:spPr>
-          <a:xfrm>
-            <a:off x="12904915" y="5660252"/>
-            <a:ext cx="302846" cy="0"/>
-          </a:xfrm>
-          <a:prstGeom prst="straightConnector1">
-            <a:avLst/>
-          </a:prstGeom>
-          <a:ln w="38100">
-            <a:tailEnd type="triangle"/>
-          </a:ln>
-        </p:spPr>
-        <p:style>
-          <a:lnRef idx="2">
-            <a:schemeClr val="dk1"/>
-          </a:lnRef>
-          <a:fillRef idx="0">
-            <a:schemeClr val="dk1"/>
-          </a:fillRef>
-          <a:effectRef idx="1">
-            <a:schemeClr val="dk1"/>
-          </a:effectRef>
-          <a:fontRef idx="minor">
-            <a:schemeClr val="tx1"/>
-          </a:fontRef>
-        </p:style>
-      </p:cxnSp>
-      <p:sp>
-        <p:nvSpPr>
-          <p:cNvPr id="33" name="TextBox 32">
-            <a:extLst>
-              <a:ext uri="{FF2B5EF4-FFF2-40B4-BE49-F238E27FC236}">
-                <a16:creationId xmlns:a16="http://schemas.microsoft.com/office/drawing/2014/main" id="{B7A2BE2B-E7C2-D2CC-BEA1-163F04CFF563}"/>
-              </a:ext>
-            </a:extLst>
-          </p:cNvPr>
-          <p:cNvSpPr txBox="1"/>
-          <p:nvPr/>
-        </p:nvSpPr>
-        <p:spPr>
-          <a:xfrm>
-            <a:off x="4796377" y="3953691"/>
-            <a:ext cx="1800000" cy="492443"/>
-          </a:xfrm>
-          <a:prstGeom prst="rect">
-            <a:avLst/>
-          </a:prstGeom>
-          <a:noFill/>
-        </p:spPr>
-        <p:txBody>
-          <a:bodyPr wrap="square" lIns="0" tIns="0" rIns="0" bIns="0" rtlCol="0">
-            <a:spAutoFit/>
-          </a:bodyPr>
-          <a:lstStyle/>
-          <a:p>
-            <a:r>
-              <a:rPr lang="en-US" sz="1600" dirty="0"/>
-              <a:t>License and installation path</a:t>
-            </a:r>
-            <a:endParaRPr lang="en-DK" sz="1600" dirty="0"/>
-          </a:p>
-        </p:txBody>
-      </p:sp>
-      <p:sp>
-        <p:nvSpPr>
-          <p:cNvPr id="34" name="TextBox 33">
-            <a:extLst>
-              <a:ext uri="{FF2B5EF4-FFF2-40B4-BE49-F238E27FC236}">
-                <a16:creationId xmlns:a16="http://schemas.microsoft.com/office/drawing/2014/main" id="{978141E0-9F45-FF89-5B8A-9FD64B93EE11}"/>
-              </a:ext>
-            </a:extLst>
-          </p:cNvPr>
-          <p:cNvSpPr txBox="1"/>
-          <p:nvPr/>
-        </p:nvSpPr>
-        <p:spPr>
-          <a:xfrm>
-            <a:off x="6899223" y="3953690"/>
-            <a:ext cx="1800000" cy="492443"/>
-          </a:xfrm>
-          <a:prstGeom prst="rect">
-            <a:avLst/>
-          </a:prstGeom>
-          <a:noFill/>
-        </p:spPr>
-        <p:txBody>
-          <a:bodyPr wrap="square" lIns="0" tIns="0" rIns="0" bIns="0" rtlCol="0">
-            <a:spAutoFit/>
-          </a:bodyPr>
-          <a:lstStyle/>
-          <a:p>
-            <a:r>
-              <a:rPr lang="en-US" sz="1600" dirty="0"/>
-              <a:t>Installation of prerequisites</a:t>
-            </a:r>
-            <a:endParaRPr lang="en-DK" sz="1600" dirty="0"/>
-          </a:p>
-        </p:txBody>
-      </p:sp>
-      <p:sp>
-        <p:nvSpPr>
-          <p:cNvPr id="35" name="TextBox 34">
-            <a:extLst>
-              <a:ext uri="{FF2B5EF4-FFF2-40B4-BE49-F238E27FC236}">
-                <a16:creationId xmlns:a16="http://schemas.microsoft.com/office/drawing/2014/main" id="{A3008F6B-3649-BC3B-EC11-FA111B8F328C}"/>
-              </a:ext>
-            </a:extLst>
-          </p:cNvPr>
-          <p:cNvSpPr txBox="1"/>
-          <p:nvPr/>
-        </p:nvSpPr>
-        <p:spPr>
-          <a:xfrm>
-            <a:off x="9002069" y="3953689"/>
-            <a:ext cx="1800000" cy="492443"/>
-          </a:xfrm>
-          <a:prstGeom prst="rect">
-            <a:avLst/>
-          </a:prstGeom>
-          <a:noFill/>
-        </p:spPr>
-        <p:txBody>
-          <a:bodyPr wrap="square" lIns="0" tIns="0" rIns="0" bIns="0" rtlCol="0">
-            <a:spAutoFit/>
-          </a:bodyPr>
-          <a:lstStyle/>
-          <a:p>
-            <a:r>
-              <a:rPr lang="en-US" sz="1600" dirty="0"/>
-              <a:t>Installation type:</a:t>
-            </a:r>
-          </a:p>
-          <a:p>
-            <a:r>
-              <a:rPr lang="en-US" sz="1600" dirty="0"/>
-              <a:t>User/Administrative</a:t>
-            </a:r>
-            <a:endParaRPr lang="en-DK" sz="1600" dirty="0"/>
-          </a:p>
-        </p:txBody>
-      </p:sp>
-      <p:sp>
-        <p:nvSpPr>
-          <p:cNvPr id="36" name="TextBox 35">
-            <a:extLst>
-              <a:ext uri="{FF2B5EF4-FFF2-40B4-BE49-F238E27FC236}">
-                <a16:creationId xmlns:a16="http://schemas.microsoft.com/office/drawing/2014/main" id="{DCBE1234-01BC-D274-4BAB-3EFEF9E7C45D}"/>
-              </a:ext>
-            </a:extLst>
-          </p:cNvPr>
-          <p:cNvSpPr txBox="1"/>
-          <p:nvPr/>
-        </p:nvSpPr>
-        <p:spPr>
-          <a:xfrm>
-            <a:off x="11104915" y="3953689"/>
-            <a:ext cx="1800000" cy="246221"/>
-          </a:xfrm>
-          <a:prstGeom prst="rect">
-            <a:avLst/>
-          </a:prstGeom>
-          <a:noFill/>
-        </p:spPr>
-        <p:txBody>
-          <a:bodyPr wrap="square" lIns="0" tIns="0" rIns="0" bIns="0" rtlCol="0">
-            <a:spAutoFit/>
-          </a:bodyPr>
-          <a:lstStyle/>
-          <a:p>
-            <a:r>
-              <a:rPr lang="en-US" sz="1600" dirty="0"/>
-              <a:t>Installation progress</a:t>
-            </a:r>
-            <a:endParaRPr lang="en-DK" sz="1600" dirty="0"/>
-          </a:p>
-        </p:txBody>
-      </p:sp>
-      <p:sp>
-        <p:nvSpPr>
-          <p:cNvPr id="37" name="TextBox 36">
-            <a:extLst>
-              <a:ext uri="{FF2B5EF4-FFF2-40B4-BE49-F238E27FC236}">
-                <a16:creationId xmlns:a16="http://schemas.microsoft.com/office/drawing/2014/main" id="{9154050E-30EF-66E7-CE86-6E8A6BE297FE}"/>
-              </a:ext>
-            </a:extLst>
-          </p:cNvPr>
-          <p:cNvSpPr txBox="1"/>
-          <p:nvPr/>
-        </p:nvSpPr>
-        <p:spPr>
-          <a:xfrm>
-            <a:off x="13207761" y="3953688"/>
-            <a:ext cx="1800000" cy="246221"/>
-          </a:xfrm>
-          <a:prstGeom prst="rect">
-            <a:avLst/>
-          </a:prstGeom>
-          <a:noFill/>
-        </p:spPr>
-        <p:txBody>
-          <a:bodyPr wrap="square" lIns="0" tIns="0" rIns="0" bIns="0" rtlCol="0">
-            <a:spAutoFit/>
-          </a:bodyPr>
-          <a:lstStyle/>
-          <a:p>
-            <a:r>
-              <a:rPr lang="en-US" sz="1600" dirty="0"/>
-              <a:t>Installation status</a:t>
-            </a:r>
-            <a:endParaRPr lang="en-DK" sz="1600" dirty="0"/>
-          </a:p>
-        </p:txBody>
-      </p:sp>
-    </p:spTree>
-    <p:extLst>
-      <p:ext uri="{BB962C8B-B14F-4D97-AF65-F5344CB8AC3E}">
-        <p14:creationId xmlns:p14="http://schemas.microsoft.com/office/powerpoint/2010/main" val="786876301"/>
-      </p:ext>
-    </p:extLst>
-  </p:cSld>
-  <p:clrMapOvr>
-    <a:masterClrMapping/>
-  </p:clrMapOvr>
-</p:sld>
-</file>
-
-<file path=ppt/slides/slide2.xml><?xml version="1.0" encoding="utf-8"?>
-<p:sld xmlns:a="http://schemas.openxmlformats.org/drawingml/2006/main" xmlns:r="http://schemas.openxmlformats.org/officeDocument/2006/relationships" xmlns:p="http://schemas.openxmlformats.org/presentationml/2006/main">
-  <p:cSld>
-    <p:spTree>
-      <p:nvGrpSpPr>
-        <p:cNvPr id="1" name=""/>
-        <p:cNvGrpSpPr/>
-        <p:nvPr/>
-      </p:nvGrpSpPr>
-      <p:grpSpPr>
-        <a:xfrm>
-          <a:off x="0" y="0"/>
-          <a:ext cx="0" cy="0"/>
-          <a:chOff x="0" y="0"/>
-          <a:chExt cx="0" cy="0"/>
-        </a:xfrm>
-      </p:grpSpPr>
-      <p:pic>
-        <p:nvPicPr>
-          <p:cNvPr id="3" name="Picture 2" descr="The image depicts a software interface for LabBench Designer, showcasing various system components such as logging, access control, and protocols, along with system information and settings.&#10;&#10;AI-generated content may be incorrect.">
-            <a:extLst>
-              <a:ext uri="{FF2B5EF4-FFF2-40B4-BE49-F238E27FC236}">
-                <a16:creationId xmlns:a16="http://schemas.microsoft.com/office/drawing/2014/main" id="{4E5FD003-555F-E1BD-759D-B8D5680A4FE2}"/>
-              </a:ext>
-            </a:extLst>
-          </p:cNvPr>
-          <p:cNvPicPr>
-            <a:picLocks noChangeAspect="1"/>
-          </p:cNvPicPr>
-          <p:nvPr/>
-        </p:nvPicPr>
-        <p:blipFill>
-          <a:blip r:embed="rId3"/>
-          <a:stretch>
-            <a:fillRect/>
-          </a:stretch>
-        </p:blipFill>
-        <p:spPr>
-          <a:xfrm>
-            <a:off x="7076916" y="4138454"/>
-            <a:ext cx="4320000" cy="2524286"/>
-          </a:xfrm>
-          <a:prstGeom prst="rect">
-            <a:avLst/>
-          </a:prstGeom>
-        </p:spPr>
-      </p:pic>
-    </p:spTree>
-    <p:extLst>
-      <p:ext uri="{BB962C8B-B14F-4D97-AF65-F5344CB8AC3E}">
-        <p14:creationId xmlns:p14="http://schemas.microsoft.com/office/powerpoint/2010/main" val="2435479675"/>
-      </p:ext>
-    </p:extLst>
-  </p:cSld>
-  <p:clrMapOvr>
-    <a:masterClrMapping/>
-  </p:clrMapOvr>
-</p:sld>
-</file>
-
-<file path=ppt/slides/slide3.xml><?xml version="1.0" encoding="utf-8"?>
-<p:sld xmlns:a="http://schemas.openxmlformats.org/drawingml/2006/main" xmlns:r="http://schemas.openxmlformats.org/officeDocument/2006/relationships" xmlns:p="http://schemas.openxmlformats.org/presentationml/2006/main">
-  <p:cSld>
-    <p:spTree>
-      <p:nvGrpSpPr>
-        <p:cNvPr id="1" name=""/>
-        <p:cNvGrpSpPr/>
-        <p:nvPr/>
-      </p:nvGrpSpPr>
-      <p:grpSpPr>
-        <a:xfrm>
-          <a:off x="0" y="0"/>
-          <a:ext cx="0" cy="0"/>
-          <a:chOff x="0" y="0"/>
-          <a:chExt cx="0" cy="0"/>
-        </a:xfrm>
-      </p:grpSpPr>
-      <p:pic>
-        <p:nvPicPr>
-          <p:cNvPr id="3" name="Picture 2" descr="The image shows a LabBench Designer software interface with tabs for various system settings, including licensing, device management, and protocols, all indicating a perpetual academic non-commercial license.&#10;&#10;AI-generated content may be incorrect.">
-            <a:extLst>
-              <a:ext uri="{FF2B5EF4-FFF2-40B4-BE49-F238E27FC236}">
-                <a16:creationId xmlns:a16="http://schemas.microsoft.com/office/drawing/2014/main" id="{B411FF9E-DC0A-FFC8-3DCB-B14F6C8C317E}"/>
-              </a:ext>
-            </a:extLst>
-          </p:cNvPr>
-          <p:cNvPicPr>
-            <a:picLocks noChangeAspect="1"/>
-          </p:cNvPicPr>
-          <p:nvPr/>
-        </p:nvPicPr>
-        <p:blipFill>
-          <a:blip r:embed="rId2"/>
-          <a:stretch>
-            <a:fillRect/>
-          </a:stretch>
-        </p:blipFill>
-        <p:spPr>
-          <a:xfrm>
-            <a:off x="6673056" y="4039394"/>
-            <a:ext cx="4320000" cy="2524286"/>
-          </a:xfrm>
-          <a:prstGeom prst="rect">
-            <a:avLst/>
-          </a:prstGeom>
-        </p:spPr>
-      </p:pic>
-      <p:sp>
-        <p:nvSpPr>
-          <p:cNvPr id="5" name="Oval 4">
-            <a:extLst>
-              <a:ext uri="{FF2B5EF4-FFF2-40B4-BE49-F238E27FC236}">
-                <a16:creationId xmlns:a16="http://schemas.microsoft.com/office/drawing/2014/main" id="{793B9558-8714-C21A-A637-EA6BBFC876B2}"/>
+                <a16:creationId xmlns:a16="http://schemas.microsoft.com/office/drawing/2014/main" id="{B9C6C6CF-DB20-C800-A6D0-C9A672AF155E}"/>
               </a:ext>
             </a:extLst>
           </p:cNvPr>
@@ -4345,14 +3663,14 @@
         </p:nvSpPr>
         <p:spPr>
           <a:xfrm>
-            <a:off x="10724845" y="4314825"/>
-            <a:ext cx="180000" cy="180000"/>
+            <a:off x="16108680" y="4991100"/>
+            <a:ext cx="419100" cy="403860"/>
           </a:xfrm>
           <a:prstGeom prst="ellipse">
             <a:avLst/>
           </a:prstGeom>
           <a:noFill/>
-          <a:ln>
+          <a:ln w="38100">
             <a:solidFill>
               <a:srgbClr val="FF0000"/>
             </a:solidFill>
@@ -4385,10 +3703,10 @@
       </p:sp>
       <p:sp>
         <p:nvSpPr>
-          <p:cNvPr id="6" name="TextBox 5">
+          <p:cNvPr id="8" name="TextBox 7">
             <a:extLst>
               <a:ext uri="{FF2B5EF4-FFF2-40B4-BE49-F238E27FC236}">
-                <a16:creationId xmlns:a16="http://schemas.microsoft.com/office/drawing/2014/main" id="{6CA8C61A-4199-F7A0-9037-91E1D6875A52}"/>
+                <a16:creationId xmlns:a16="http://schemas.microsoft.com/office/drawing/2014/main" id="{00C10F4E-5121-F10A-3278-3EB13B48F891}"/>
               </a:ext>
             </a:extLst>
           </p:cNvPr>
@@ -4397,8 +3715,8 @@
         </p:nvSpPr>
         <p:spPr>
           <a:xfrm>
-            <a:off x="10023594" y="3532347"/>
-            <a:ext cx="1585049" cy="338554"/>
+            <a:off x="11125200" y="3543300"/>
+            <a:ext cx="3195490" cy="523220"/>
           </a:xfrm>
           <a:prstGeom prst="rect">
             <a:avLst/>
@@ -4412,37 +3730,37 @@
           <a:lstStyle/>
           <a:p>
             <a:r>
-              <a:rPr lang="en-US" sz="1600" dirty="0"/>
-              <a:t>Register license</a:t>
-            </a:r>
-            <a:endParaRPr lang="en-DK" sz="1600" dirty="0"/>
+              <a:rPr lang="en-US" sz="2800" dirty="0"/>
+              <a:t>Build the repository</a:t>
+            </a:r>
+            <a:endParaRPr lang="en-DK" sz="2800" dirty="0"/>
           </a:p>
         </p:txBody>
       </p:sp>
       <p:cxnSp>
         <p:nvCxnSpPr>
-          <p:cNvPr id="8" name="Straight Arrow Connector 7">
+          <p:cNvPr id="12" name="Connector: Elbow 11">
             <a:extLst>
               <a:ext uri="{FF2B5EF4-FFF2-40B4-BE49-F238E27FC236}">
-                <a16:creationId xmlns:a16="http://schemas.microsoft.com/office/drawing/2014/main" id="{71475FAF-714A-E6A4-E899-AF0CC4A06A9E}"/>
+                <a16:creationId xmlns:a16="http://schemas.microsoft.com/office/drawing/2014/main" id="{A3429E61-CC84-FFD4-A7C4-75AC42467A93}"/>
               </a:ext>
             </a:extLst>
           </p:cNvPr>
           <p:cNvCxnSpPr>
-            <a:stCxn id="6" idx="2"/>
-            <a:endCxn id="5" idx="0"/>
+            <a:stCxn id="8" idx="3"/>
+            <a:endCxn id="6" idx="0"/>
           </p:cNvCxnSpPr>
           <p:nvPr/>
         </p:nvCxnSpPr>
         <p:spPr>
-          <a:xfrm flipH="1">
-            <a:off x="10814845" y="3870901"/>
-            <a:ext cx="1274" cy="443924"/>
+          <a:xfrm>
+            <a:off x="14320690" y="3804910"/>
+            <a:ext cx="1997540" cy="1186190"/>
           </a:xfrm>
-          <a:prstGeom prst="straightConnector1">
+          <a:prstGeom prst="bentConnector2">
             <a:avLst/>
           </a:prstGeom>
-          <a:ln>
+          <a:ln w="38100">
             <a:solidFill>
               <a:srgbClr val="FF0000"/>
             </a:solidFill>
@@ -4451,13 +3769,13 @@
         </p:spPr>
         <p:style>
           <a:lnRef idx="2">
-            <a:schemeClr val="dk1"/>
+            <a:schemeClr val="accent1"/>
           </a:lnRef>
           <a:fillRef idx="0">
-            <a:schemeClr val="dk1"/>
+            <a:schemeClr val="accent1"/>
           </a:fillRef>
           <a:effectRef idx="1">
-            <a:schemeClr val="dk1"/>
+            <a:schemeClr val="accent1"/>
           </a:effectRef>
           <a:fontRef idx="minor">
             <a:schemeClr val="tx1"/>
@@ -4467,395 +3785,7 @@
     </p:spTree>
     <p:extLst>
       <p:ext uri="{BB962C8B-B14F-4D97-AF65-F5344CB8AC3E}">
-        <p14:creationId xmlns:p14="http://schemas.microsoft.com/office/powerpoint/2010/main" val="1151588778"/>
-      </p:ext>
-    </p:extLst>
-  </p:cSld>
-  <p:clrMapOvr>
-    <a:masterClrMapping/>
-  </p:clrMapOvr>
-</p:sld>
-</file>
-
-<file path=ppt/slides/slide4.xml><?xml version="1.0" encoding="utf-8"?>
-<p:sld xmlns:a="http://schemas.openxmlformats.org/drawingml/2006/main" xmlns:r="http://schemas.openxmlformats.org/officeDocument/2006/relationships" xmlns:p="http://schemas.openxmlformats.org/presentationml/2006/main">
-  <p:cSld>
-    <p:spTree>
-      <p:nvGrpSpPr>
-        <p:cNvPr id="1" name=""/>
-        <p:cNvGrpSpPr/>
-        <p:nvPr/>
-      </p:nvGrpSpPr>
-      <p:grpSpPr>
-        <a:xfrm>
-          <a:off x="0" y="0"/>
-          <a:ext cx="0" cy="0"/>
-          <a:chOff x="0" y="0"/>
-          <a:chExt cx="0" cy="0"/>
-        </a:xfrm>
-      </p:grpSpPr>
-      <p:pic>
-        <p:nvPicPr>
-          <p:cNvPr id="3" name="Picture 2" descr="Register&#10;&#10;AI-generated content may be incorrect.">
-            <a:extLst>
-              <a:ext uri="{FF2B5EF4-FFF2-40B4-BE49-F238E27FC236}">
-                <a16:creationId xmlns:a16="http://schemas.microsoft.com/office/drawing/2014/main" id="{2C34065E-C8D6-8E5C-654C-AC9A4188B57B}"/>
-              </a:ext>
-            </a:extLst>
-          </p:cNvPr>
-          <p:cNvPicPr>
-            <a:picLocks noChangeAspect="1"/>
-          </p:cNvPicPr>
-          <p:nvPr/>
-        </p:nvPicPr>
-        <p:blipFill>
-          <a:blip r:embed="rId2"/>
-          <a:stretch>
-            <a:fillRect/>
-          </a:stretch>
-        </p:blipFill>
-        <p:spPr>
-          <a:xfrm>
-            <a:off x="6745902" y="4298058"/>
-            <a:ext cx="1800000" cy="986667"/>
-          </a:xfrm>
-          <a:prstGeom prst="rect">
-            <a:avLst/>
-          </a:prstGeom>
-        </p:spPr>
-      </p:pic>
-    </p:spTree>
-    <p:extLst>
-      <p:ext uri="{BB962C8B-B14F-4D97-AF65-F5344CB8AC3E}">
-        <p14:creationId xmlns:p14="http://schemas.microsoft.com/office/powerpoint/2010/main" val="3211259048"/>
-      </p:ext>
-    </p:extLst>
-  </p:cSld>
-  <p:clrMapOvr>
-    <a:masterClrMapping/>
-  </p:clrMapOvr>
-</p:sld>
-</file>
-
-<file path=ppt/slides/slide5.xml><?xml version="1.0" encoding="utf-8"?>
-<p:sld xmlns:a="http://schemas.openxmlformats.org/drawingml/2006/main" xmlns:r="http://schemas.openxmlformats.org/officeDocument/2006/relationships" xmlns:p="http://schemas.openxmlformats.org/presentationml/2006/main">
-  <p:cSld>
-    <p:spTree>
-      <p:nvGrpSpPr>
-        <p:cNvPr id="1" name=""/>
-        <p:cNvGrpSpPr/>
-        <p:nvPr/>
-      </p:nvGrpSpPr>
-      <p:grpSpPr>
-        <a:xfrm>
-          <a:off x="0" y="0"/>
-          <a:ext cx="0" cy="0"/>
-          <a:chOff x="0" y="0"/>
-          <a:chExt cx="0" cy="0"/>
-        </a:xfrm>
-      </p:grpSpPr>
-      <p:pic>
-        <p:nvPicPr>
-          <p:cNvPr id="6" name="Picture 5" descr="The image displays a LabBench Designer software interface with a valid, perpetual commercial license, featuring sections for logging, access control, display calibration, and license holder details.&#10;&#10;AI-generated content may be incorrect.">
-            <a:extLst>
-              <a:ext uri="{FF2B5EF4-FFF2-40B4-BE49-F238E27FC236}">
-                <a16:creationId xmlns:a16="http://schemas.microsoft.com/office/drawing/2014/main" id="{1CC9F33C-7EE7-3986-8260-949C20038E97}"/>
-              </a:ext>
-            </a:extLst>
-          </p:cNvPr>
-          <p:cNvPicPr>
-            <a:picLocks noChangeAspect="1"/>
-          </p:cNvPicPr>
-          <p:nvPr/>
-        </p:nvPicPr>
-        <p:blipFill>
-          <a:blip r:embed="rId2"/>
-          <a:stretch>
-            <a:fillRect/>
-          </a:stretch>
-        </p:blipFill>
-        <p:spPr>
-          <a:xfrm>
-            <a:off x="6657181" y="4199732"/>
-            <a:ext cx="4320000" cy="2598134"/>
-          </a:xfrm>
-          <a:prstGeom prst="rect">
-            <a:avLst/>
-          </a:prstGeom>
-        </p:spPr>
-      </p:pic>
-      <p:sp>
-        <p:nvSpPr>
-          <p:cNvPr id="4" name="Oval 3">
-            <a:extLst>
-              <a:ext uri="{FF2B5EF4-FFF2-40B4-BE49-F238E27FC236}">
-                <a16:creationId xmlns:a16="http://schemas.microsoft.com/office/drawing/2014/main" id="{7EC621E5-5D25-B9B0-3B22-DA89395988C3}"/>
-              </a:ext>
-            </a:extLst>
-          </p:cNvPr>
-          <p:cNvSpPr/>
-          <p:nvPr/>
-        </p:nvSpPr>
-        <p:spPr>
-          <a:xfrm>
-            <a:off x="10663983" y="4848226"/>
-            <a:ext cx="180000" cy="180000"/>
-          </a:xfrm>
-          <a:prstGeom prst="ellipse">
-            <a:avLst/>
-          </a:prstGeom>
-          <a:noFill/>
-          <a:ln>
-            <a:solidFill>
-              <a:srgbClr val="FF0000"/>
-            </a:solidFill>
-          </a:ln>
-        </p:spPr>
-        <p:style>
-          <a:lnRef idx="2">
-            <a:schemeClr val="accent1">
-              <a:shade val="15000"/>
-            </a:schemeClr>
-          </a:lnRef>
-          <a:fillRef idx="1">
-            <a:schemeClr val="accent1"/>
-          </a:fillRef>
-          <a:effectRef idx="0">
-            <a:schemeClr val="accent1"/>
-          </a:effectRef>
-          <a:fontRef idx="minor">
-            <a:schemeClr val="lt1"/>
-          </a:fontRef>
-        </p:style>
-        <p:txBody>
-          <a:bodyPr rtlCol="0" anchor="ctr"/>
-          <a:lstStyle/>
-          <a:p>
-            <a:pPr algn="ctr"/>
-            <a:endParaRPr lang="en-DK"/>
-          </a:p>
-        </p:txBody>
-      </p:sp>
-      <p:sp>
-        <p:nvSpPr>
-          <p:cNvPr id="7" name="Oval 6">
-            <a:extLst>
-              <a:ext uri="{FF2B5EF4-FFF2-40B4-BE49-F238E27FC236}">
-                <a16:creationId xmlns:a16="http://schemas.microsoft.com/office/drawing/2014/main" id="{BF0E1A9A-3D50-01F9-752E-74E7C68435E3}"/>
-              </a:ext>
-            </a:extLst>
-          </p:cNvPr>
-          <p:cNvSpPr/>
-          <p:nvPr/>
-        </p:nvSpPr>
-        <p:spPr>
-          <a:xfrm>
-            <a:off x="10444908" y="4848226"/>
-            <a:ext cx="180000" cy="180000"/>
-          </a:xfrm>
-          <a:prstGeom prst="ellipse">
-            <a:avLst/>
-          </a:prstGeom>
-          <a:noFill/>
-          <a:ln>
-            <a:solidFill>
-              <a:srgbClr val="FF0000"/>
-            </a:solidFill>
-          </a:ln>
-        </p:spPr>
-        <p:style>
-          <a:lnRef idx="2">
-            <a:schemeClr val="accent1">
-              <a:shade val="15000"/>
-            </a:schemeClr>
-          </a:lnRef>
-          <a:fillRef idx="1">
-            <a:schemeClr val="accent1"/>
-          </a:fillRef>
-          <a:effectRef idx="0">
-            <a:schemeClr val="accent1"/>
-          </a:effectRef>
-          <a:fontRef idx="minor">
-            <a:schemeClr val="lt1"/>
-          </a:fontRef>
-        </p:style>
-        <p:txBody>
-          <a:bodyPr rtlCol="0" anchor="ctr"/>
-          <a:lstStyle/>
-          <a:p>
-            <a:pPr algn="ctr"/>
-            <a:endParaRPr lang="en-DK"/>
-          </a:p>
-        </p:txBody>
-      </p:sp>
-      <p:sp>
-        <p:nvSpPr>
-          <p:cNvPr id="8" name="TextBox 7">
-            <a:extLst>
-              <a:ext uri="{FF2B5EF4-FFF2-40B4-BE49-F238E27FC236}">
-                <a16:creationId xmlns:a16="http://schemas.microsoft.com/office/drawing/2014/main" id="{A093A94B-6B34-85E8-E68F-7F1428F6C73C}"/>
-              </a:ext>
-            </a:extLst>
-          </p:cNvPr>
-          <p:cNvSpPr txBox="1"/>
-          <p:nvPr/>
-        </p:nvSpPr>
-        <p:spPr>
-          <a:xfrm>
-            <a:off x="9761907" y="3771179"/>
-            <a:ext cx="1546001" cy="338554"/>
-          </a:xfrm>
-          <a:prstGeom prst="rect">
-            <a:avLst/>
-          </a:prstGeom>
-          <a:noFill/>
-        </p:spPr>
-        <p:txBody>
-          <a:bodyPr wrap="none" rtlCol="0">
-            <a:spAutoFit/>
-          </a:bodyPr>
-          <a:lstStyle/>
-          <a:p>
-            <a:r>
-              <a:rPr lang="en-US" sz="1600" dirty="0"/>
-              <a:t>Refresh license</a:t>
-            </a:r>
-            <a:endParaRPr lang="en-DK" sz="1600" dirty="0"/>
-          </a:p>
-        </p:txBody>
-      </p:sp>
-      <p:sp>
-        <p:nvSpPr>
-          <p:cNvPr id="9" name="TextBox 8">
-            <a:extLst>
-              <a:ext uri="{FF2B5EF4-FFF2-40B4-BE49-F238E27FC236}">
-                <a16:creationId xmlns:a16="http://schemas.microsoft.com/office/drawing/2014/main" id="{22FF1A3A-17E0-3797-DAD4-00CF309CE56E}"/>
-              </a:ext>
-            </a:extLst>
-          </p:cNvPr>
-          <p:cNvSpPr txBox="1"/>
-          <p:nvPr/>
-        </p:nvSpPr>
-        <p:spPr>
-          <a:xfrm>
-            <a:off x="11103094" y="4768949"/>
-            <a:ext cx="1572866" cy="338554"/>
-          </a:xfrm>
-          <a:prstGeom prst="rect">
-            <a:avLst/>
-          </a:prstGeom>
-          <a:noFill/>
-        </p:spPr>
-        <p:txBody>
-          <a:bodyPr wrap="none" rtlCol="0">
-            <a:spAutoFit/>
-          </a:bodyPr>
-          <a:lstStyle/>
-          <a:p>
-            <a:r>
-              <a:rPr lang="en-US" sz="1600" dirty="0"/>
-              <a:t>Release license</a:t>
-            </a:r>
-            <a:endParaRPr lang="en-DK" sz="1600" dirty="0"/>
-          </a:p>
-        </p:txBody>
-      </p:sp>
-      <p:cxnSp>
-        <p:nvCxnSpPr>
-          <p:cNvPr id="10" name="Straight Arrow Connector 9">
-            <a:extLst>
-              <a:ext uri="{FF2B5EF4-FFF2-40B4-BE49-F238E27FC236}">
-                <a16:creationId xmlns:a16="http://schemas.microsoft.com/office/drawing/2014/main" id="{94BF7280-2F65-6320-D37B-DEB00283B36A}"/>
-              </a:ext>
-            </a:extLst>
-          </p:cNvPr>
-          <p:cNvCxnSpPr>
-            <a:cxnSpLocks/>
-            <a:stCxn id="8" idx="2"/>
-            <a:endCxn id="7" idx="0"/>
-          </p:cNvCxnSpPr>
-          <p:nvPr/>
-        </p:nvCxnSpPr>
-        <p:spPr>
-          <a:xfrm>
-            <a:off x="10534908" y="4109733"/>
-            <a:ext cx="0" cy="738493"/>
-          </a:xfrm>
-          <a:prstGeom prst="straightConnector1">
-            <a:avLst/>
-          </a:prstGeom>
-          <a:ln>
-            <a:solidFill>
-              <a:srgbClr val="FF0000"/>
-            </a:solidFill>
-            <a:tailEnd type="triangle"/>
-          </a:ln>
-        </p:spPr>
-        <p:style>
-          <a:lnRef idx="2">
-            <a:schemeClr val="dk1"/>
-          </a:lnRef>
-          <a:fillRef idx="0">
-            <a:schemeClr val="dk1"/>
-          </a:fillRef>
-          <a:effectRef idx="1">
-            <a:schemeClr val="dk1"/>
-          </a:effectRef>
-          <a:fontRef idx="minor">
-            <a:schemeClr val="tx1"/>
-          </a:fontRef>
-        </p:style>
-      </p:cxnSp>
-      <p:cxnSp>
-        <p:nvCxnSpPr>
-          <p:cNvPr id="13" name="Straight Arrow Connector 12">
-            <a:extLst>
-              <a:ext uri="{FF2B5EF4-FFF2-40B4-BE49-F238E27FC236}">
-                <a16:creationId xmlns:a16="http://schemas.microsoft.com/office/drawing/2014/main" id="{E03505D3-0492-7122-A758-0BE2E5D4D4F3}"/>
-              </a:ext>
-            </a:extLst>
-          </p:cNvPr>
-          <p:cNvCxnSpPr>
-            <a:cxnSpLocks/>
-            <a:stCxn id="9" idx="1"/>
-            <a:endCxn id="4" idx="6"/>
-          </p:cNvCxnSpPr>
-          <p:nvPr/>
-        </p:nvCxnSpPr>
-        <p:spPr>
-          <a:xfrm flipH="1">
-            <a:off x="10843983" y="4938226"/>
-            <a:ext cx="259111" cy="0"/>
-          </a:xfrm>
-          <a:prstGeom prst="straightConnector1">
-            <a:avLst/>
-          </a:prstGeom>
-          <a:ln>
-            <a:solidFill>
-              <a:srgbClr val="FF0000"/>
-            </a:solidFill>
-            <a:tailEnd type="triangle"/>
-          </a:ln>
-        </p:spPr>
-        <p:style>
-          <a:lnRef idx="2">
-            <a:schemeClr val="dk1"/>
-          </a:lnRef>
-          <a:fillRef idx="0">
-            <a:schemeClr val="dk1"/>
-          </a:fillRef>
-          <a:effectRef idx="1">
-            <a:schemeClr val="dk1"/>
-          </a:effectRef>
-          <a:fontRef idx="minor">
-            <a:schemeClr val="tx1"/>
-          </a:fontRef>
-        </p:style>
-      </p:cxnSp>
-    </p:spTree>
-    <p:extLst>
-      <p:ext uri="{BB962C8B-B14F-4D97-AF65-F5344CB8AC3E}">
-        <p14:creationId xmlns:p14="http://schemas.microsoft.com/office/powerpoint/2010/main" val="1948937592"/>
+        <p14:creationId xmlns:p14="http://schemas.microsoft.com/office/powerpoint/2010/main" val="786876301"/>
       </p:ext>
     </p:extLst>
   </p:cSld>
@@ -5751,15 +4681,6 @@
 </file>
 
 <file path=customXml/item2.xml><?xml version="1.0" encoding="utf-8"?>
-<?mso-contentType ?>
-<FormTemplates xmlns="http://schemas.microsoft.com/sharepoint/v3/contenttype/forms">
-  <Display>DocumentLibraryForm</Display>
-  <Edit>DocumentLibraryForm</Edit>
-  <New>DocumentLibraryForm</New>
-</FormTemplates>
-</file>
-
-<file path=customXml/item3.xml><?xml version="1.0" encoding="utf-8"?>
 <p:properties xmlns:p="http://schemas.microsoft.com/office/2006/metadata/properties" xmlns:xsi="http://www.w3.org/2001/XMLSchema-instance" xmlns:pc="http://schemas.microsoft.com/office/infopath/2007/PartnerControls">
   <documentManagement>
     <TaxCatchAll xmlns="6dfb7b4b-871d-4c24-9d42-16b14ecd044c" xsi:nil="true"/>
@@ -5768,6 +4689,15 @@
     </lcf76f155ced4ddcb4097134ff3c332f>
   </documentManagement>
 </p:properties>
+</file>
+
+<file path=customXml/item3.xml><?xml version="1.0" encoding="utf-8"?>
+<?mso-contentType ?>
+<FormTemplates xmlns="http://schemas.microsoft.com/sharepoint/v3/contenttype/forms">
+  <Display>DocumentLibraryForm</Display>
+  <Edit>DocumentLibraryForm</Edit>
+  <New>DocumentLibraryForm</New>
+</FormTemplates>
 </file>
 
 <file path=customXml/itemProps1.xml><?xml version="1.0" encoding="utf-8"?>
@@ -5790,14 +4720,6 @@
 </file>
 
 <file path=customXml/itemProps2.xml><?xml version="1.0" encoding="utf-8"?>
-<ds:datastoreItem xmlns:ds="http://schemas.openxmlformats.org/officeDocument/2006/customXml" ds:itemID="{EF875D47-8106-485E-98E0-D60C6A98DA6A}">
-  <ds:schemaRefs>
-    <ds:schemaRef ds:uri="http://schemas.microsoft.com/sharepoint/v3/contenttype/forms"/>
-  </ds:schemaRefs>
-</ds:datastoreItem>
-</file>
-
-<file path=customXml/itemProps3.xml><?xml version="1.0" encoding="utf-8"?>
 <ds:datastoreItem xmlns:ds="http://schemas.openxmlformats.org/officeDocument/2006/customXml" ds:itemID="{2EF670CE-B0AA-4D52-AFC6-AA4BF7D46EEA}">
   <ds:schemaRefs>
     <ds:schemaRef ds:uri="http://schemas.microsoft.com/office/2006/metadata/properties"/>
@@ -5806,4 +4728,12 @@
     <ds:schemaRef ds:uri="51c7d8ad-74c8-4833-8478-0d0a5cafce0c"/>
   </ds:schemaRefs>
 </ds:datastoreItem>
+</file>
+
+<file path=customXml/itemProps3.xml><?xml version="1.0" encoding="utf-8"?>
+<ds:datastoreItem xmlns:ds="http://schemas.openxmlformats.org/officeDocument/2006/customXml" ds:itemID="{EF875D47-8106-485E-98E0-D60C6A98DA6A}">
+  <ds:schemaRefs>
+    <ds:schemaRef ds:uri="http://schemas.microsoft.com/sharepoint/v3/contenttype/forms"/>
+  </ds:schemaRefs>
+</ds:datastoreItem>
 </file>
</xml_diff>